<commit_message>
GraphRAG 검색 에이전트를 Opus에서 Groq gpt-oss-120b로 변경
- 예제: ③ 검색 에이전트를 ChatGroq로, 비용 표시를 Groq 공식 단가로, 필요 키 3개(Claude 키 제거),
  Anthropic 캐시 미들웨어와 패키지 제거. 실습 함수 13개는 그대로
- 문서: README 실측(답변 완료 16/20, 함정 5/5와 15/15, 25문항 에이전트 비용 $0.04)과 Opus 비교,
  실습 가이드와 슬라이드, 개발계획서 16장, ReAct 설계 문서에 변경 기록
- 교재 장표 스크립트와 코드 예시 장표를 Groq 기준으로 갱신

Co-Authored-By: Claude Opus 5.5 <noreply@anthropic.com>
</commit_message>
<xml_diff>
--- a/teacher/plan/graph-search-code.pptx
+++ b/teacher/plan/graph-search-code.pptx
@@ -704,7 +704,7 @@
               <a:t>3. 검색: ⑦ 수집 종료 판정 – 코드 재확인 실제 코드
 교육생 실습 함수 recheck_question(빈칸 2곳)의 정답임. 빈칸은 조건 ①의 공존 문장 수와 조건 ②의 관계 확인
 통과한 뒤에는 제공 함수 decide_collection이 Jev 판정을 봄. 답 근거 원문이 0개면 불통과, 전제 충돌은 통과 + 표시
-함정 5문항 × 3회 실측: 15번 모두 「확인할 수 없음」, 그중 14번을 ⑦이 막음. 대가로 낱말이 다른 질문(Q14 「해지」와 「정리」)은 오거절됨
+함정 5문항 × 3회 실측(에이전트 Groq): 15번 모두 「확인할 수 없음」이고 모두 ⑦이 막음. 대가로 낱말이 다른 질문(Q14 「해지」와 「정리」)은 오거절됨
 코드: hands-on/solutions/graphrag/retriever/(core_search.py의 recheck_question). 줄 끝 주석은 장표에서 뺌
 상세 문서: https://github.com/unicorn-campus/hybrid-ai/blob/main/hands-on/solutions/graphrag/retriever/core_search.py</a:t>
             </a:r>
@@ -982,8 +982,8 @@
               <a:rPr lang="en-US" dirty="0"/>
               <a:t>3. 검색: ⑩ 종료 상태 – 실제 코드
 교육생 실습 함수 make_end_state(빈칸 1곳)의 정답임
-화면 맨 끝에는 Opus 실제 비용(응답의 토큰 사용량 × 단가)과 호출 수, 툴 경로가 찍힘
-평가셋 25문항 마지막 실행: 답 있는 20문항 중 답변 완료 18, 함정 5/5 확인할 수 없음, Opus 비용 합계 $0.75
+화면 맨 끝에는 ③ 에이전트(Groq) 실제 비용(응답의 토큰 사용량 × 단가)과 호출 수, 툴 경로가 찍힘
+평가셋 25문항 마지막 실행(에이전트 Groq): 답 있는 20문항 중 답변 완료 16, 함정 5/5 확인할 수 없음, 에이전트 비용 합계 $0.0415
 코드: hands-on/solutions/graphrag/retriever/(core_search.py의 END_STATES, make_end_state). 줄 끝 주석은 장표에서 뺌
 상세 문서: https://github.com/unicorn-campus/hybrid-ai/blob/main/hands-on/solutions/graphrag/retriever/core_search.py</a:t>
             </a:r>
@@ -1075,8 +1075,8 @@
               <a:rPr lang="en-US" dirty="0"/>
               <a:t>3. 검색: ③ 검색 에이전트 – 실제 코드
 교육생 실습 함수 build_agent(빈칸 2곳)의 정답임. 빈칸은 create_agent 호출과 invoke 호출
-메시지는 덧붙이기만 됨(append-only). Opus 5.5는 이전 턴을 고치면 생각 블록이 깨질 수 있음
-툴 강제 옵션과 temperature는 Opus 5.5에서 400 오류라 보내지 않음
+메시지는 덧붙이기만 됨(append-only). 앞부분이 같은 입력은 Groq가 자동으로 캐시해 회차가 늘어도 입력 비용이 작음
+에이전트 모델은 처음 설계의 Claude Opus 5.5에서 Groq로 바꿈(강사 결정 2026-10-25). 비교 실험에서 품질은 거의 같고 더 빠르고 쌌음
 코드: hands-on/solutions/graphrag/retriever/(core_search.py의 build_agent). 줄 끝 주석은 장표에서 뺌
 상세 문서: https://github.com/unicorn-campus/hybrid-ai/blob/main/hands-on/solutions/graphrag/retriever/core_search.py</a:t>
             </a:r>
@@ -14138,7 +14138,7 @@
                 <a:ea typeface="Pretendard" pitchFamily="34" charset="-122"/>
                 <a:cs typeface="Pretendard" pitchFamily="34" charset="-120"/>
               </a:rPr>
-              <a:t>이름, 뜻, 이유, 답, 근거 목록, 경고. main이 Opus 비용을 덧붙여 화면에 찍음</a:t>
+              <a:t>이름, 뜻, 이유, 답, 근거 목록, 경고. main이 에이전트 비용을 덧붙여 화면에 찍음</a:t>
             </a:r>
             <a:endParaRPr lang="en-US" sz="1800" dirty="0"/>
           </a:p>
@@ -15710,7 +15710,7 @@
                 <a:ea typeface="Pretendard" pitchFamily="34" charset="-122"/>
                 <a:cs typeface="Pretendard" pitchFamily="34" charset="-120"/>
               </a:rPr>
-              <a:t>❷ Opus 5.5</a:t>
+              <a:t>❷ Groq gpt-oss-120b</a:t>
             </a:r>
             <a:endParaRPr lang="en-US" sz="1500" dirty="0"/>
           </a:p>
@@ -15727,7 +15727,7 @@
                 <a:ea typeface="Pretendard" pitchFamily="34" charset="-122"/>
                 <a:cs typeface="Pretendard" pitchFamily="34" charset="-120"/>
               </a:rPr>
-              <a:t>다음 툴과 질의를 고름. effort medium, 생각은 끌 수 없음</a:t>
+              <a:t>다음 툴과 질의를 고름. G1, G2, ⑧과 같은 모델, reasoning_effort medium</a:t>
             </a:r>
             <a:endParaRPr lang="en-US" sz="1500" dirty="0"/>
           </a:p>
@@ -15861,7 +15861,7 @@
                 <a:ea typeface="Pretendard" pitchFamily="34" charset="-122"/>
                 <a:cs typeface="Pretendard" pitchFamily="34" charset="-120"/>
               </a:rPr>
-              <a:t>상한과 강제 종료(GuardMiddleware), 래퍼와 채점(ToolWrapperMiddleware), 프롬프트 캐시</a:t>
+              <a:t>상한과 강제 종료(GuardMiddleware), 래퍼와 채점(ToolWrapperMiddleware)</a:t>
             </a:r>
             <a:endParaRPr lang="en-US" sz="1500" dirty="0"/>
           </a:p>
@@ -29397,7 +29397,7 @@
                           <a:ea typeface="Pretendard" pitchFamily="34" charset="-122"/>
                           <a:cs typeface="Pretendard" pitchFamily="34" charset="-120"/>
                         </a:rPr>
-                        <a:t>    say(f"\n── ③ 회차 {ctx['rounds'] + 1}/{MAX_ROUNDS}: Opus 호출")</a:t>
+                        <a:t>    say(f"\n── ③ 회차 {ctx['rounds'] + 1}/{MAX_ROUNDS}: 에이전트(Groq) 호출")</a:t>
                       </a:r>
                       <a:endParaRPr lang="en-US" sz="1200" dirty="0">
                         <a:latin typeface="Pretendard" charset="0"/>

</xml_diff>